<commit_message>
Vigil: updated build, hosted demo page
</commit_message>
<xml_diff>
--- a/Vigil_deck.pptx
+++ b/Vigil_deck.pptx
@@ -4290,7 +4290,7 @@
                   <a:srgbClr val="55D68A"/>
                 </a:solidFill>
               </a:rPr>
-              <a:t>Six AI employees, one human Director</a:t>
+              <a:t>Six workers, one human Director</a:t>
             </a:r>
           </a:p>
         </p:txBody>
@@ -4419,6 +4419,21 @@
                 </a:solidFill>
               </a:rPr>
               <a:t>The Director approves every family message and every removal dispatch.</a:t>
+            </a:r>
+          </a:p>
+          <a:p>
+            <a:pPr>
+              <a:spcAft>
+                <a:spcPts val="1000"/>
+              </a:spcAft>
+            </a:pPr>
+            <a:r>
+              <a:rPr sz="2400">
+                <a:solidFill>
+                  <a:srgbClr val="E8E8E8"/>
+                </a:solidFill>
+              </a:rPr>
+              <a:t>Honest note: the workers are deterministic code today, not LLM agents.</a:t>
             </a:r>
           </a:p>
         </p:txBody>
@@ -4753,7 +4768,7 @@
                   <a:srgbClr val="E8E8E8"/>
                 </a:solidFill>
               </a:rPr>
-              <a:t>n8n: dispatch workflow: webhook fires the first-call on-call workflow</a:t>
+              <a:t>n8n: workflow round trip: webhook sends a dispatch ticket to a live n8n workflow (it does not move a real removal team)</a:t>
             </a:r>
           </a:p>
           <a:p>
@@ -4798,7 +4813,7 @@
                   <a:srgbClr val="E8E8E8"/>
                 </a:solidFill>
               </a:rPr>
-              <a:t>Snyk: dependency/code security scan gate</a:t>
+              <a:t>Snyk: dependency vulnerability scan; real findings (exit 1) block dispatch</a:t>
             </a:r>
           </a:p>
           <a:p>
@@ -4843,7 +4858,7 @@
                   <a:srgbClr val="E8E8E8"/>
                 </a:solidFill>
               </a:rPr>
-              <a:t>BAND: shared agent/human channel</a:t>
+              <a:t>BAND: post case updates into a BAND room with the Director as a participant</a:t>
             </a:r>
           </a:p>
           <a:p>
@@ -4873,7 +4888,7 @@
                   <a:srgbClr val="E8E8E8"/>
                 </a:solidFill>
               </a:rPr>
-              <a:t>Flatkey: credential gateway</a:t>
+              <a:t>Flatkey: model API / failover gateway (not a key vault)</a:t>
             </a:r>
           </a:p>
           <a:p>
@@ -4888,7 +4903,7 @@
                   <a:srgbClr val="E8E8E8"/>
                 </a:solidFill>
               </a:rPr>
-              <a:t>Paritok: usage metering</a:t>
+              <a:t>Paritok: context/session compression (not metering)</a:t>
             </a:r>
           </a:p>
           <a:p>
@@ -4918,7 +4933,7 @@
                   <a:srgbClr val="E8E8E8"/>
                 </a:solidFill>
               </a:rPr>
-              <a:t>Status shown per run in the demo: REAL / SIMULATED / FALLBACK / EXTERNAL. Today: 0 real, all simulated; flips as keys land.</a:t>
+              <a:t>Status shown per run in the demo: REAL / SIMULATED / FALLBACK / EXTERNAL. Today: n8n real (workflow round trip), Prelint external, 9 simulated.</a:t>
             </a:r>
           </a:p>
         </p:txBody>
@@ -5063,7 +5078,7 @@
                   <a:srgbClr val="E8E8E8"/>
                 </a:solidFill>
               </a:rPr>
-              <a:t>Every run reports which steps were real, simulated, fallback or external (34 automated tests).</a:t>
+              <a:t>Every run reports which steps were real, simulated, fallback or external (55 automated tests).</a:t>
             </a:r>
           </a:p>
           <a:p>

</xml_diff>

<commit_message>
Vigil: add PromptQL demo, avatars, updated deck and Pages
</commit_message>
<xml_diff>
--- a/Vigil_deck.pptx
+++ b/Vigil_deck.pptx
@@ -4323,12 +4323,12 @@
               </a:spcAft>
             </a:pPr>
             <a:r>
-              <a:rPr sz="2400">
+              <a:rPr sz="1500">
                 <a:solidFill>
                   <a:srgbClr val="E8E8E8"/>
                 </a:solidFill>
               </a:rPr>
-              <a:t>Mara - Intake (reports to Director)</a:t>
+              <a:t>Mara intake, Quinn quoter, Sol scheduler, Paige paperwork, Faye family liaison, Lex compliance logger. All report to the human Director.</a:t>
             </a:r>
           </a:p>
           <a:p>
@@ -4338,12 +4338,12 @@
               </a:spcAft>
             </a:pPr>
             <a:r>
-              <a:rPr sz="2400">
+              <a:rPr sz="1500">
                 <a:solidFill>
                   <a:srgbClr val="E8E8E8"/>
                 </a:solidFill>
               </a:rPr>
-              <a:t>Quinn - Quoter (reports to Director)</a:t>
+              <a:t>The Director approves every family message and every removal dispatch.</a:t>
             </a:r>
           </a:p>
           <a:p>
@@ -4353,87 +4353,12 @@
               </a:spcAft>
             </a:pPr>
             <a:r>
-              <a:rPr sz="2400">
+              <a:rPr sz="1500">
                 <a:solidFill>
                   <a:srgbClr val="E8E8E8"/>
                 </a:solidFill>
               </a:rPr>
-              <a:t>Sol - Scheduler (reports to Director)</a:t>
-            </a:r>
-          </a:p>
-          <a:p>
-            <a:pPr>
-              <a:spcAft>
-                <a:spcPts val="1000"/>
-              </a:spcAft>
-            </a:pPr>
-            <a:r>
-              <a:rPr sz="2400">
-                <a:solidFill>
-                  <a:srgbClr val="E8E8E8"/>
-                </a:solidFill>
-              </a:rPr>
-              <a:t>Paige - Paperwork (reports to Director)</a:t>
-            </a:r>
-          </a:p>
-          <a:p>
-            <a:pPr>
-              <a:spcAft>
-                <a:spcPts val="1000"/>
-              </a:spcAft>
-            </a:pPr>
-            <a:r>
-              <a:rPr sz="2400">
-                <a:solidFill>
-                  <a:srgbClr val="E8E8E8"/>
-                </a:solidFill>
-              </a:rPr>
-              <a:t>Faye - Family Liaison (reports to Director)</a:t>
-            </a:r>
-          </a:p>
-          <a:p>
-            <a:pPr>
-              <a:spcAft>
-                <a:spcPts val="1000"/>
-              </a:spcAft>
-            </a:pPr>
-            <a:r>
-              <a:rPr sz="2400">
-                <a:solidFill>
-                  <a:srgbClr val="E8E8E8"/>
-                </a:solidFill>
-              </a:rPr>
-              <a:t>Lex - Compliance Logger (reports to Director)</a:t>
-            </a:r>
-          </a:p>
-          <a:p>
-            <a:pPr>
-              <a:spcAft>
-                <a:spcPts val="1000"/>
-              </a:spcAft>
-            </a:pPr>
-            <a:r>
-              <a:rPr sz="2400">
-                <a:solidFill>
-                  <a:srgbClr val="E8E8E8"/>
-                </a:solidFill>
-              </a:rPr>
-              <a:t>The Director approves every family message and every removal dispatch.</a:t>
-            </a:r>
-          </a:p>
-          <a:p>
-            <a:pPr>
-              <a:spcAft>
-                <a:spcPts val="1000"/>
-              </a:spcAft>
-            </a:pPr>
-            <a:r>
-              <a:rPr sz="2400">
-                <a:solidFill>
-                  <a:srgbClr val="E8E8E8"/>
-                </a:solidFill>
-              </a:rPr>
-              <a:t>Honest note: Mara (intake) and Faye (family drafts) are OpenAI-assisted ($3 cap, lint + approval + fallback). Quinn, Sol, Paige, Lex are deterministic code.</a:t>
+              <a:t>Honest note: Mara and Faye are OpenAI-assisted ($3 cap, lint + approval + fallback). Quinn, Sol, Paige, Lex are deterministic code.</a:t>
             </a:r>
           </a:p>
         </p:txBody>
@@ -4467,6 +4392,381 @@
                 </a:solidFill>
               </a:rPr>
               <a:t>Fictional data. Each sponsor integration shows its true mode; no real call is placed.</a:t>
+            </a:r>
+          </a:p>
+        </p:txBody>
+      </p:sp>
+      <p:pic>
+        <p:nvPicPr>
+          <p:cNvPr id="5" name="Picture 4" descr="mara_deck.jpg"/>
+          <p:cNvPicPr>
+            <a:picLocks noChangeAspect="1"/>
+          </p:cNvPicPr>
+          <p:nvPr/>
+        </p:nvPicPr>
+        <p:blipFill>
+          <a:blip r:embed="rId3"/>
+          <a:stretch>
+            <a:fillRect/>
+          </a:stretch>
+        </p:blipFill>
+        <p:spPr>
+          <a:xfrm>
+            <a:off x="640080" y="4389120"/>
+            <a:ext cx="1645920" cy="1645920"/>
+          </a:xfrm>
+          <a:prstGeom prst="rect">
+            <a:avLst/>
+          </a:prstGeom>
+        </p:spPr>
+      </p:pic>
+      <p:sp>
+        <p:nvSpPr>
+          <p:cNvPr id="6" name="TextBox 5"/>
+          <p:cNvSpPr txBox="1"/>
+          <p:nvPr/>
+        </p:nvSpPr>
+        <p:spPr>
+          <a:xfrm>
+            <a:off x="640080" y="6035040"/>
+            <a:ext cx="1737360" cy="320040"/>
+          </a:xfrm>
+          <a:prstGeom prst="rect">
+            <a:avLst/>
+          </a:prstGeom>
+          <a:noFill/>
+        </p:spPr>
+        <p:txBody>
+          <a:bodyPr wrap="none">
+            <a:spAutoFit/>
+          </a:bodyPr>
+          <a:lstStyle/>
+          <a:p>
+            <a:r>
+              <a:rPr sz="1400">
+                <a:solidFill>
+                  <a:srgbClr val="E8E8E8"/>
+                </a:solidFill>
+              </a:rPr>
+              <a:t>Mara</a:t>
+            </a:r>
+          </a:p>
+        </p:txBody>
+      </p:sp>
+      <p:pic>
+        <p:nvPicPr>
+          <p:cNvPr id="7" name="Picture 6" descr="quinn_deck.jpg"/>
+          <p:cNvPicPr>
+            <a:picLocks noChangeAspect="1"/>
+          </p:cNvPicPr>
+          <p:nvPr/>
+        </p:nvPicPr>
+        <p:blipFill>
+          <a:blip r:embed="rId4"/>
+          <a:stretch>
+            <a:fillRect/>
+          </a:stretch>
+        </p:blipFill>
+        <p:spPr>
+          <a:xfrm>
+            <a:off x="2514600" y="4389120"/>
+            <a:ext cx="1645920" cy="1645920"/>
+          </a:xfrm>
+          <a:prstGeom prst="rect">
+            <a:avLst/>
+          </a:prstGeom>
+        </p:spPr>
+      </p:pic>
+      <p:sp>
+        <p:nvSpPr>
+          <p:cNvPr id="8" name="TextBox 7"/>
+          <p:cNvSpPr txBox="1"/>
+          <p:nvPr/>
+        </p:nvSpPr>
+        <p:spPr>
+          <a:xfrm>
+            <a:off x="2514600" y="6035040"/>
+            <a:ext cx="1737360" cy="320040"/>
+          </a:xfrm>
+          <a:prstGeom prst="rect">
+            <a:avLst/>
+          </a:prstGeom>
+          <a:noFill/>
+        </p:spPr>
+        <p:txBody>
+          <a:bodyPr wrap="none">
+            <a:spAutoFit/>
+          </a:bodyPr>
+          <a:lstStyle/>
+          <a:p>
+            <a:r>
+              <a:rPr sz="1400">
+                <a:solidFill>
+                  <a:srgbClr val="E8E8E8"/>
+                </a:solidFill>
+              </a:rPr>
+              <a:t>Quinn</a:t>
+            </a:r>
+          </a:p>
+        </p:txBody>
+      </p:sp>
+      <p:pic>
+        <p:nvPicPr>
+          <p:cNvPr id="9" name="Picture 8" descr="sol_deck.jpg"/>
+          <p:cNvPicPr>
+            <a:picLocks noChangeAspect="1"/>
+          </p:cNvPicPr>
+          <p:nvPr/>
+        </p:nvPicPr>
+        <p:blipFill>
+          <a:blip r:embed="rId5"/>
+          <a:stretch>
+            <a:fillRect/>
+          </a:stretch>
+        </p:blipFill>
+        <p:spPr>
+          <a:xfrm>
+            <a:off x="4389120" y="4389120"/>
+            <a:ext cx="1645920" cy="1645920"/>
+          </a:xfrm>
+          <a:prstGeom prst="rect">
+            <a:avLst/>
+          </a:prstGeom>
+        </p:spPr>
+      </p:pic>
+      <p:sp>
+        <p:nvSpPr>
+          <p:cNvPr id="10" name="TextBox 9"/>
+          <p:cNvSpPr txBox="1"/>
+          <p:nvPr/>
+        </p:nvSpPr>
+        <p:spPr>
+          <a:xfrm>
+            <a:off x="4389120" y="6035040"/>
+            <a:ext cx="1737360" cy="320040"/>
+          </a:xfrm>
+          <a:prstGeom prst="rect">
+            <a:avLst/>
+          </a:prstGeom>
+          <a:noFill/>
+        </p:spPr>
+        <p:txBody>
+          <a:bodyPr wrap="none">
+            <a:spAutoFit/>
+          </a:bodyPr>
+          <a:lstStyle/>
+          <a:p>
+            <a:r>
+              <a:rPr sz="1400">
+                <a:solidFill>
+                  <a:srgbClr val="E8E8E8"/>
+                </a:solidFill>
+              </a:rPr>
+              <a:t>Sol</a:t>
+            </a:r>
+          </a:p>
+        </p:txBody>
+      </p:sp>
+      <p:pic>
+        <p:nvPicPr>
+          <p:cNvPr id="11" name="Picture 10" descr="paige_deck.jpg"/>
+          <p:cNvPicPr>
+            <a:picLocks noChangeAspect="1"/>
+          </p:cNvPicPr>
+          <p:nvPr/>
+        </p:nvPicPr>
+        <p:blipFill>
+          <a:blip r:embed="rId6"/>
+          <a:stretch>
+            <a:fillRect/>
+          </a:stretch>
+        </p:blipFill>
+        <p:spPr>
+          <a:xfrm>
+            <a:off x="6263640" y="4389120"/>
+            <a:ext cx="1645920" cy="1645920"/>
+          </a:xfrm>
+          <a:prstGeom prst="rect">
+            <a:avLst/>
+          </a:prstGeom>
+        </p:spPr>
+      </p:pic>
+      <p:sp>
+        <p:nvSpPr>
+          <p:cNvPr id="12" name="TextBox 11"/>
+          <p:cNvSpPr txBox="1"/>
+          <p:nvPr/>
+        </p:nvSpPr>
+        <p:spPr>
+          <a:xfrm>
+            <a:off x="6263640" y="6035040"/>
+            <a:ext cx="1737360" cy="320040"/>
+          </a:xfrm>
+          <a:prstGeom prst="rect">
+            <a:avLst/>
+          </a:prstGeom>
+          <a:noFill/>
+        </p:spPr>
+        <p:txBody>
+          <a:bodyPr wrap="none">
+            <a:spAutoFit/>
+          </a:bodyPr>
+          <a:lstStyle/>
+          <a:p>
+            <a:r>
+              <a:rPr sz="1400">
+                <a:solidFill>
+                  <a:srgbClr val="E8E8E8"/>
+                </a:solidFill>
+              </a:rPr>
+              <a:t>Paige</a:t>
+            </a:r>
+          </a:p>
+        </p:txBody>
+      </p:sp>
+      <p:pic>
+        <p:nvPicPr>
+          <p:cNvPr id="13" name="Picture 12" descr="faye_deck.jpg"/>
+          <p:cNvPicPr>
+            <a:picLocks noChangeAspect="1"/>
+          </p:cNvPicPr>
+          <p:nvPr/>
+        </p:nvPicPr>
+        <p:blipFill>
+          <a:blip r:embed="rId7"/>
+          <a:stretch>
+            <a:fillRect/>
+          </a:stretch>
+        </p:blipFill>
+        <p:spPr>
+          <a:xfrm>
+            <a:off x="8138159" y="4389120"/>
+            <a:ext cx="1645920" cy="1645920"/>
+          </a:xfrm>
+          <a:prstGeom prst="rect">
+            <a:avLst/>
+          </a:prstGeom>
+        </p:spPr>
+      </p:pic>
+      <p:sp>
+        <p:nvSpPr>
+          <p:cNvPr id="14" name="TextBox 13"/>
+          <p:cNvSpPr txBox="1"/>
+          <p:nvPr/>
+        </p:nvSpPr>
+        <p:spPr>
+          <a:xfrm>
+            <a:off x="8138159" y="6035040"/>
+            <a:ext cx="1737360" cy="320040"/>
+          </a:xfrm>
+          <a:prstGeom prst="rect">
+            <a:avLst/>
+          </a:prstGeom>
+          <a:noFill/>
+        </p:spPr>
+        <p:txBody>
+          <a:bodyPr wrap="none">
+            <a:spAutoFit/>
+          </a:bodyPr>
+          <a:lstStyle/>
+          <a:p>
+            <a:r>
+              <a:rPr sz="1400">
+                <a:solidFill>
+                  <a:srgbClr val="E8E8E8"/>
+                </a:solidFill>
+              </a:rPr>
+              <a:t>Faye</a:t>
+            </a:r>
+          </a:p>
+        </p:txBody>
+      </p:sp>
+      <p:pic>
+        <p:nvPicPr>
+          <p:cNvPr id="15" name="Picture 14" descr="vera_deck.jpg"/>
+          <p:cNvPicPr>
+            <a:picLocks noChangeAspect="1"/>
+          </p:cNvPicPr>
+          <p:nvPr/>
+        </p:nvPicPr>
+        <p:blipFill>
+          <a:blip r:embed="rId8"/>
+          <a:stretch>
+            <a:fillRect/>
+          </a:stretch>
+        </p:blipFill>
+        <p:spPr>
+          <a:xfrm>
+            <a:off x="10012680" y="4389120"/>
+            <a:ext cx="1645920" cy="1645920"/>
+          </a:xfrm>
+          <a:prstGeom prst="rect">
+            <a:avLst/>
+          </a:prstGeom>
+        </p:spPr>
+      </p:pic>
+      <p:sp>
+        <p:nvSpPr>
+          <p:cNvPr id="16" name="TextBox 15"/>
+          <p:cNvSpPr txBox="1"/>
+          <p:nvPr/>
+        </p:nvSpPr>
+        <p:spPr>
+          <a:xfrm>
+            <a:off x="10012680" y="6035040"/>
+            <a:ext cx="1737360" cy="320040"/>
+          </a:xfrm>
+          <a:prstGeom prst="rect">
+            <a:avLst/>
+          </a:prstGeom>
+          <a:noFill/>
+        </p:spPr>
+        <p:txBody>
+          <a:bodyPr wrap="none">
+            <a:spAutoFit/>
+          </a:bodyPr>
+          <a:lstStyle/>
+          <a:p>
+            <a:r>
+              <a:rPr sz="1400">
+                <a:solidFill>
+                  <a:srgbClr val="E8E8E8"/>
+                </a:solidFill>
+              </a:rPr>
+              <a:t>Lex</a:t>
+            </a:r>
+          </a:p>
+        </p:txBody>
+      </p:sp>
+      <p:sp>
+        <p:nvSpPr>
+          <p:cNvPr id="17" name="TextBox 16"/>
+          <p:cNvSpPr txBox="1"/>
+          <p:nvPr/>
+        </p:nvSpPr>
+        <p:spPr>
+          <a:xfrm>
+            <a:off x="640080" y="3931920"/>
+            <a:ext cx="5486400" cy="320040"/>
+          </a:xfrm>
+          <a:prstGeom prst="rect">
+            <a:avLst/>
+          </a:prstGeom>
+          <a:noFill/>
+        </p:spPr>
+        <p:txBody>
+          <a:bodyPr wrap="none">
+            <a:spAutoFit/>
+          </a:bodyPr>
+          <a:lstStyle/>
+          <a:p>
+            <a:r>
+              <a:rPr sz="1200">
+                <a:solidFill>
+                  <a:srgbClr val="AAAAAA"/>
+                </a:solidFill>
+              </a:rPr>
+              <a:t>avatars: Masky (AI, fictional)</a:t>
             </a:r>
           </a:p>
         </p:txBody>
@@ -4873,7 +5173,7 @@
                   <a:srgbClr val="E8E8E8"/>
                 </a:solidFill>
               </a:rPr>
-              <a:t>PromptQL: natural-language ledger queries</a:t>
+              <a:t>Paritok: context compression gateway sitting between Vigil and the OpenAI API (prompts here are tiny, so savings are ~0; we label that)</a:t>
             </a:r>
           </a:p>
           <a:p>
@@ -4888,7 +5188,7 @@
                   <a:srgbClr val="E8E8E8"/>
                 </a:solidFill>
               </a:rPr>
-              <a:t>Flatkey: model API / failover gateway (not a key vault)</a:t>
+              <a:t>PromptQL: natural-language ledger queries</a:t>
             </a:r>
           </a:p>
           <a:p>
@@ -4903,7 +5203,7 @@
                   <a:srgbClr val="E8E8E8"/>
                 </a:solidFill>
               </a:rPr>
-              <a:t>Paritok: context/session compression (not metering)</a:t>
+              <a:t>Flatkey: model API / failover gateway (not a key vault)</a:t>
             </a:r>
           </a:p>
           <a:p>

</xml_diff>

<commit_message>
Vigil: add voice clips, six staff cards and handoff log
</commit_message>
<xml_diff>
--- a/Vigil_deck.pptx
+++ b/Vigil_deck.pptx
@@ -4358,7 +4358,7 @@
                   <a:srgbClr val="E8E8E8"/>
                 </a:solidFill>
               </a:rPr>
-              <a:t>Honest note: Mara and Faye are OpenAI-assisted ($3 cap, lint + approval + fallback). Quinn, Sol, Paige, Lex are deterministic code.</a:t>
+              <a:t>Honest note: all six are LLM-driven (gpt-4o-mini, $3 cap): each makes one decision plus an in-character line. Gates, prices, callback time and approvals are deterministic code. Front office: Mara, Faye. Back office: Quinn, Sol, Paige, Lex.</a:t>
             </a:r>
           </a:p>
         </p:txBody>
@@ -5143,7 +5143,7 @@
                   <a:srgbClr val="E8E8E8"/>
                 </a:solidFill>
               </a:rPr>
-              <a:t>Tenki: CI runner for the test suite</a:t>
+              <a:t>Tenki: CI runner for the test suite (repo-side) and a sandbox VM that re-runs Lex's compliance lint</a:t>
             </a:r>
           </a:p>
           <a:p>
@@ -5174,6 +5174,21 @@
                 </a:solidFill>
               </a:rPr>
               <a:t>Paritok: context compression gateway sitting between Vigil and the OpenAI API (prompts here are tiny, so savings are ~0; we label that)</a:t>
+            </a:r>
+          </a:p>
+          <a:p>
+            <a:pPr>
+              <a:spcAft>
+                <a:spcPts val="1000"/>
+              </a:spcAft>
+            </a:pPr>
+            <a:r>
+              <a:rPr sz="1600">
+                <a:solidFill>
+                  <a:srgbClr val="E8E8E8"/>
+                </a:solidFill>
+              </a:rPr>
+              <a:t>Glasser: bounded public web research for a funeral-home prospect list (one recorded query, never contacts anyone)</a:t>
             </a:r>
           </a:p>
           <a:p>

</xml_diff>

<commit_message>
Vigil: rename Lex to Vera and verify Tenki sandbox
</commit_message>
<xml_diff>
--- a/Vigil_deck.pptx
+++ b/Vigil_deck.pptx
@@ -4328,7 +4328,7 @@
                   <a:srgbClr val="E8E8E8"/>
                 </a:solidFill>
               </a:rPr>
-              <a:t>Mara intake, Quinn quoter, Sol scheduler, Paige paperwork, Faye family liaison, Lex compliance logger. All report to the human Director.</a:t>
+              <a:t>Mara intake, Quinn quoter, Sol scheduler, Paige paperwork, Faye family liaison, Vera compliance logger. All report to the human Director.</a:t>
             </a:r>
           </a:p>
           <a:p>
@@ -4358,7 +4358,7 @@
                   <a:srgbClr val="E8E8E8"/>
                 </a:solidFill>
               </a:rPr>
-              <a:t>Honest note: all six are LLM-driven (gpt-4o-mini, $3 cap): each makes one decision plus an in-character line. Gates, prices, callback time and approvals are deterministic code. Front office: Mara, Faye. Back office: Quinn, Sol, Paige, Lex.</a:t>
+              <a:t>Honest note: all six are LLM-driven (gpt-4o-mini, $3 cap): each makes one decision plus an in-character line. Gates, prices, callback time and approvals are deterministic code. Front office: Mara, Faye. Back office: Quinn, Sol, Paige, Vera.</a:t>
             </a:r>
           </a:p>
         </p:txBody>
@@ -4733,7 +4733,7 @@
                   <a:srgbClr val="E8E8E8"/>
                 </a:solidFill>
               </a:rPr>
-              <a:t>Lex</a:t>
+              <a:t>Vera</a:t>
             </a:r>
           </a:p>
         </p:txBody>
@@ -4908,7 +4908,7 @@
                   <a:srgbClr val="E8E8E8"/>
                 </a:solidFill>
               </a:rPr>
-              <a:t>Check: Lex lints for recording disclosure and no arrangement-making.</a:t>
+              <a:t>Check: Vera lints for recording disclosure and no arrangement-making.</a:t>
             </a:r>
           </a:p>
           <a:p>
@@ -5143,7 +5143,7 @@
                   <a:srgbClr val="E8E8E8"/>
                 </a:solidFill>
               </a:rPr>
-              <a:t>Tenki: CI runner for the test suite (repo-side) and a sandbox VM that re-runs Lex's compliance lint</a:t>
+              <a:t>Tenki: CI runner for the test suite (repo-side) and a sandbox VM that re-runs Vera's compliance lint</a:t>
             </a:r>
           </a:p>
           <a:p>

</xml_diff>

<commit_message>
Vigil: show all sponsor cards in demo replay
</commit_message>
<xml_diff>
--- a/Vigil_deck.pptx
+++ b/Vigil_deck.pptx
@@ -788,7 +788,7 @@
           <a:lstStyle/>
           <a:p>
             <a:r>
-              <a:t>Be honest and update the status line to the live count before presenting.</a:t>
+              <a:t>The status line is the recorded run; re-check it before presenting.</a:t>
             </a:r>
           </a:p>
         </p:txBody>
@@ -5063,7 +5063,7 @@
               </a:spcAft>
             </a:pPr>
             <a:r>
-              <a:rPr sz="1600">
+              <a:rPr sz="1400">
                 <a:solidFill>
                   <a:srgbClr val="E8E8E8"/>
                 </a:solidFill>
@@ -5078,7 +5078,7 @@
               </a:spcAft>
             </a:pPr>
             <a:r>
-              <a:rPr sz="1600">
+              <a:rPr sz="1400">
                 <a:solidFill>
                   <a:srgbClr val="E8E8E8"/>
                 </a:solidFill>
@@ -5093,7 +5093,7 @@
               </a:spcAft>
             </a:pPr>
             <a:r>
-              <a:rPr sz="1600">
+              <a:rPr sz="1400">
                 <a:solidFill>
                   <a:srgbClr val="E8E8E8"/>
                 </a:solidFill>
@@ -5108,7 +5108,7 @@
               </a:spcAft>
             </a:pPr>
             <a:r>
-              <a:rPr sz="1600">
+              <a:rPr sz="1400">
                 <a:solidFill>
                   <a:srgbClr val="E8E8E8"/>
                 </a:solidFill>
@@ -5123,7 +5123,7 @@
               </a:spcAft>
             </a:pPr>
             <a:r>
-              <a:rPr sz="1600">
+              <a:rPr sz="1400">
                 <a:solidFill>
                   <a:srgbClr val="E8E8E8"/>
                 </a:solidFill>
@@ -5138,7 +5138,7 @@
               </a:spcAft>
             </a:pPr>
             <a:r>
-              <a:rPr sz="1600">
+              <a:rPr sz="1400">
                 <a:solidFill>
                   <a:srgbClr val="E8E8E8"/>
                 </a:solidFill>
@@ -5153,7 +5153,7 @@
               </a:spcAft>
             </a:pPr>
             <a:r>
-              <a:rPr sz="1600">
+              <a:rPr sz="1400">
                 <a:solidFill>
                   <a:srgbClr val="E8E8E8"/>
                 </a:solidFill>
@@ -5168,7 +5168,7 @@
               </a:spcAft>
             </a:pPr>
             <a:r>
-              <a:rPr sz="1600">
+              <a:rPr sz="1400">
                 <a:solidFill>
                   <a:srgbClr val="E8E8E8"/>
                 </a:solidFill>
@@ -5183,7 +5183,7 @@
               </a:spcAft>
             </a:pPr>
             <a:r>
-              <a:rPr sz="1600">
+              <a:rPr sz="1400">
                 <a:solidFill>
                   <a:srgbClr val="E8E8E8"/>
                 </a:solidFill>
@@ -5198,7 +5198,7 @@
               </a:spcAft>
             </a:pPr>
             <a:r>
-              <a:rPr sz="1600">
+              <a:rPr sz="1400">
                 <a:solidFill>
                   <a:srgbClr val="E8E8E8"/>
                 </a:solidFill>
@@ -5213,7 +5213,7 @@
               </a:spcAft>
             </a:pPr>
             <a:r>
-              <a:rPr sz="1600">
+              <a:rPr sz="1400">
                 <a:solidFill>
                   <a:srgbClr val="E8E8E8"/>
                 </a:solidFill>
@@ -5228,7 +5228,7 @@
               </a:spcAft>
             </a:pPr>
             <a:r>
-              <a:rPr sz="1600">
+              <a:rPr sz="1400">
                 <a:solidFill>
                   <a:srgbClr val="E8E8E8"/>
                 </a:solidFill>
@@ -5243,12 +5243,12 @@
               </a:spcAft>
             </a:pPr>
             <a:r>
-              <a:rPr sz="1600">
+              <a:rPr sz="1400">
                 <a:solidFill>
                   <a:srgbClr val="E8E8E8"/>
                 </a:solidFill>
               </a:rPr>
-              <a:t>Status shown per run in the demo: REAL / SIMULATED / FALLBACK / EXTERNAL. Today: n8n, Snyk, BAND real; Prelint external; 7 simulated.</a:t>
+              <a:t>Recorded run: REAL = n8n, Snyk, BAND, Celesto, Paritok, Glasser, Tenki (sandbox runs Vera's lint). EXTERNAL = Prelint, Tenki CI (repo-side). SIMULATED = RocketRide, PromptQL, Flatkey, Masky.</a:t>
             </a:r>
           </a:p>
         </p:txBody>

</xml_diff>

<commit_message>
Vigil: clarify PromptQL replay results and update deck
</commit_message>
<xml_diff>
--- a/Vigil_deck.pptx
+++ b/Vigil_deck.pptx
@@ -12,6 +12,7 @@
     <p:sldId id="260" r:id="rId12"/>
     <p:sldId id="261" r:id="rId13"/>
     <p:sldId id="262" r:id="rId14"/>
+    <p:sldId id="263" r:id="rId15"/>
   </p:sldIdLst>
   <p:sldSz cx="12191695" cy="6858000" type="screen4x3"/>
   <p:notesSz cx="6858000" cy="9144000"/>
@@ -884,6 +885,72 @@
 </file>
 
 <file path=ppt/notesSlides/notesSlide7.xml><?xml version="1.0" encoding="utf-8"?>
+<p:notes xmlns:a="http://schemas.openxmlformats.org/drawingml/2006/main" xmlns:p="http://schemas.openxmlformats.org/presentationml/2006/main" xmlns:r="http://schemas.openxmlformats.org/officeDocument/2006/relationships">
+  <p:cSld>
+    <p:spTree>
+      <p:nvGrpSpPr>
+        <p:cNvPr id="1" name=""/>
+        <p:cNvGrpSpPr/>
+        <p:nvPr/>
+      </p:nvGrpSpPr>
+      <p:grpSpPr>
+        <a:xfrm>
+          <a:off x="0" y="0"/>
+          <a:ext cx="0" cy="0"/>
+          <a:chOff x="0" y="0"/>
+          <a:chExt cx="0" cy="0"/>
+        </a:xfrm>
+      </p:grpSpPr>
+      <p:sp>
+        <p:nvSpPr>
+          <p:cNvPr id="2" name="Slide Image Placeholder 1"/>
+          <p:cNvSpPr>
+            <a:spLocks noGrp="1"/>
+          </p:cNvSpPr>
+          <p:nvPr>
+            <p:ph type="sldImg" idx="2"/>
+          </p:nvPr>
+        </p:nvSpPr>
+        <p:spPr/>
+      </p:sp>
+      <p:sp>
+        <p:nvSpPr>
+          <p:cNvPr id="3" name="Notes Placeholder 2"/>
+          <p:cNvSpPr>
+            <a:spLocks noGrp="1"/>
+          </p:cNvSpPr>
+          <p:nvPr>
+            <p:ph type="body" idx="3" sz="quarter"/>
+          </p:nvPr>
+        </p:nvSpPr>
+        <p:spPr/>
+        <p:txBody>
+          <a:bodyPr/>
+          <a:lstStyle/>
+          <a:p/>
+        </p:txBody>
+      </p:sp>
+      <p:sp>
+        <p:nvSpPr>
+          <p:cNvPr id="4" name="Slide Number Placeholder 3"/>
+          <p:cNvSpPr>
+            <a:spLocks noGrp="1"/>
+          </p:cNvSpPr>
+          <p:nvPr>
+            <p:ph type="sldNum" idx="5" sz="quarter"/>
+          </p:nvPr>
+        </p:nvSpPr>
+        <p:spPr/>
+      </p:sp>
+    </p:spTree>
+  </p:cSld>
+  <p:clrMapOvr>
+    <a:masterClrMapping/>
+  </p:clrMapOvr>
+</p:notes>
+</file>
+
+<file path=ppt/notesSlides/notesSlide8.xml><?xml version="1.0" encoding="utf-8"?>
 <p:notes xmlns:a="http://schemas.openxmlformats.org/drawingml/2006/main" xmlns:p="http://schemas.openxmlformats.org/presentationml/2006/main" xmlns:r="http://schemas.openxmlformats.org/officeDocument/2006/relationships">
   <p:cSld>
     <p:spTree>
@@ -5063,7 +5130,7 @@
               </a:spcAft>
             </a:pPr>
             <a:r>
-              <a:rPr sz="1400">
+              <a:rPr sz="1200">
                 <a:solidFill>
                   <a:srgbClr val="E8E8E8"/>
                 </a:solidFill>
@@ -5078,7 +5145,7 @@
               </a:spcAft>
             </a:pPr>
             <a:r>
-              <a:rPr sz="1400">
+              <a:rPr sz="1200">
                 <a:solidFill>
                   <a:srgbClr val="E8E8E8"/>
                 </a:solidFill>
@@ -5093,7 +5160,7 @@
               </a:spcAft>
             </a:pPr>
             <a:r>
-              <a:rPr sz="1400">
+              <a:rPr sz="1200">
                 <a:solidFill>
                   <a:srgbClr val="E8E8E8"/>
                 </a:solidFill>
@@ -5108,7 +5175,7 @@
               </a:spcAft>
             </a:pPr>
             <a:r>
-              <a:rPr sz="1400">
+              <a:rPr sz="1200">
                 <a:solidFill>
                   <a:srgbClr val="E8E8E8"/>
                 </a:solidFill>
@@ -5123,7 +5190,7 @@
               </a:spcAft>
             </a:pPr>
             <a:r>
-              <a:rPr sz="1400">
+              <a:rPr sz="1200">
                 <a:solidFill>
                   <a:srgbClr val="E8E8E8"/>
                 </a:solidFill>
@@ -5138,7 +5205,7 @@
               </a:spcAft>
             </a:pPr>
             <a:r>
-              <a:rPr sz="1400">
+              <a:rPr sz="1200">
                 <a:solidFill>
                   <a:srgbClr val="E8E8E8"/>
                 </a:solidFill>
@@ -5153,7 +5220,7 @@
               </a:spcAft>
             </a:pPr>
             <a:r>
-              <a:rPr sz="1400">
+              <a:rPr sz="1200">
                 <a:solidFill>
                   <a:srgbClr val="E8E8E8"/>
                 </a:solidFill>
@@ -5168,7 +5235,7 @@
               </a:spcAft>
             </a:pPr>
             <a:r>
-              <a:rPr sz="1400">
+              <a:rPr sz="1200">
                 <a:solidFill>
                   <a:srgbClr val="E8E8E8"/>
                 </a:solidFill>
@@ -5183,7 +5250,7 @@
               </a:spcAft>
             </a:pPr>
             <a:r>
-              <a:rPr sz="1400">
+              <a:rPr sz="1200">
                 <a:solidFill>
                   <a:srgbClr val="E8E8E8"/>
                 </a:solidFill>
@@ -5198,7 +5265,7 @@
               </a:spcAft>
             </a:pPr>
             <a:r>
-              <a:rPr sz="1400">
+              <a:rPr sz="1200">
                 <a:solidFill>
                   <a:srgbClr val="E8E8E8"/>
                 </a:solidFill>
@@ -5213,7 +5280,7 @@
               </a:spcAft>
             </a:pPr>
             <a:r>
-              <a:rPr sz="1400">
+              <a:rPr sz="1200">
                 <a:solidFill>
                   <a:srgbClr val="E8E8E8"/>
                 </a:solidFill>
@@ -5228,12 +5295,12 @@
               </a:spcAft>
             </a:pPr>
             <a:r>
-              <a:rPr sz="1400">
+              <a:rPr sz="1200">
                 <a:solidFill>
                   <a:srgbClr val="E8E8E8"/>
                 </a:solidFill>
               </a:rPr>
-              <a:t>Masky: avatar for Faye</a:t>
+              <a:t>Masky: avatar portraits for the six agents</a:t>
             </a:r>
           </a:p>
           <a:p>
@@ -5243,12 +5310,12 @@
               </a:spcAft>
             </a:pPr>
             <a:r>
-              <a:rPr sz="1400">
+              <a:rPr sz="1200">
                 <a:solidFill>
                   <a:srgbClr val="E8E8E8"/>
                 </a:solidFill>
               </a:rPr>
-              <a:t>Recorded run: REAL = n8n, Snyk, BAND, Celesto, Paritok, Glasser, Tenki (sandbox runs Vera's lint). EXTERNAL = Prelint, Tenki CI (repo-side). SIMULATED = RocketRide, PromptQL, Flatkey, Masky.</a:t>
+              <a:t>Recorded run: REAL = n8n, Snyk, BAND, Celesto, Paritok, Glasser, Tenki (sandbox runs Vera's lint). EXTERNAL = Prelint, Tenki CI (repo-side). SIMULATED = RocketRide, PromptQL, Flatkey, Masky. PromptQL: 3/3 verified answers in the PromptQL workspace on the pasted price list and ledger; no runtime API call. Masky: six portraits generated in Masky (real assets); no runtime API call.</a:t>
             </a:r>
           </a:p>
         </p:txBody>
@@ -5470,6 +5537,211 @@
 </file>
 
 <file path=ppt/slides/slide7.xml><?xml version="1.0" encoding="utf-8"?>
+<p:sld xmlns:a="http://schemas.openxmlformats.org/drawingml/2006/main" xmlns:p="http://schemas.openxmlformats.org/presentationml/2006/main" xmlns:r="http://schemas.openxmlformats.org/officeDocument/2006/relationships">
+  <p:cSld>
+    <p:bg>
+      <p:bgPr>
+        <a:solidFill>
+          <a:srgbClr val="12151A"/>
+        </a:solidFill>
+        <a:effectLst/>
+      </p:bgPr>
+    </p:bg>
+    <p:spTree>
+      <p:nvGrpSpPr>
+        <p:cNvPr id="1" name=""/>
+        <p:cNvGrpSpPr/>
+        <p:nvPr/>
+      </p:nvGrpSpPr>
+      <p:grpSpPr/>
+      <p:sp>
+        <p:nvSpPr>
+          <p:cNvPr id="2" name="TextBox 1"/>
+          <p:cNvSpPr txBox="1"/>
+          <p:nvPr/>
+        </p:nvSpPr>
+        <p:spPr>
+          <a:xfrm>
+            <a:off x="640080" y="457200"/>
+            <a:ext cx="10972800" cy="1005840"/>
+          </a:xfrm>
+          <a:prstGeom prst="rect">
+            <a:avLst/>
+          </a:prstGeom>
+          <a:noFill/>
+        </p:spPr>
+        <p:txBody>
+          <a:bodyPr wrap="square">
+            <a:spAutoFit/>
+          </a:bodyPr>
+          <a:lstStyle/>
+          <a:p>
+            <a:r>
+              <a:rPr sz="3800" b="1">
+                <a:solidFill>
+                  <a:srgbClr val="55D68A"/>
+                </a:solidFill>
+              </a:rPr>
+              <a:t>Where this is submitted</a:t>
+            </a:r>
+          </a:p>
+        </p:txBody>
+      </p:sp>
+      <p:sp>
+        <p:nvSpPr>
+          <p:cNvPr id="3" name="TextBox 2"/>
+          <p:cNvSpPr txBox="1"/>
+          <p:nvPr/>
+        </p:nvSpPr>
+        <p:spPr>
+          <a:xfrm>
+            <a:off x="640080" y="1645920"/>
+            <a:ext cx="10972800" cy="4572000"/>
+          </a:xfrm>
+          <a:prstGeom prst="rect">
+            <a:avLst/>
+          </a:prstGeom>
+          <a:noFill/>
+        </p:spPr>
+        <p:txBody>
+          <a:bodyPr wrap="square">
+            <a:spAutoFit/>
+          </a:bodyPr>
+          <a:lstStyle/>
+          <a:p>
+            <a:pPr>
+              <a:spcAft>
+                <a:spcPts val="1000"/>
+              </a:spcAft>
+            </a:pPr>
+            <a:r>
+              <a:rPr sz="2200">
+                <a:solidFill>
+                  <a:srgbClr val="E8E8E8"/>
+                </a:solidFill>
+              </a:rPr>
+              <a:t>1. Crewbase: hackathons.crewbasecollective.com (project name, app URL, GitHub repo)</a:t>
+            </a:r>
+          </a:p>
+          <a:p>
+            <a:pPr>
+              <a:spcAft>
+                <a:spcPts val="1000"/>
+              </a:spcAft>
+            </a:pPr>
+            <a:r>
+              <a:rPr sz="2200">
+                <a:solidFill>
+                  <a:srgbClr val="E8E8E8"/>
+                </a:solidFill>
+              </a:rPr>
+              <a:t>2. Masky form</a:t>
+            </a:r>
+          </a:p>
+          <a:p>
+            <a:pPr>
+              <a:spcAft>
+                <a:spcPts val="1000"/>
+              </a:spcAft>
+            </a:pPr>
+            <a:r>
+              <a:rPr sz="2200">
+                <a:solidFill>
+                  <a:srgbClr val="E8E8E8"/>
+                </a:solidFill>
+              </a:rPr>
+              <a:t>3. Masky: deck URL posted in the twitch.tv/aijudge chat</a:t>
+            </a:r>
+          </a:p>
+          <a:p>
+            <a:pPr>
+              <a:spcAft>
+                <a:spcPts val="1000"/>
+              </a:spcAft>
+            </a:pPr>
+            <a:r>
+              <a:rPr sz="2200">
+                <a:solidFill>
+                  <a:srgbClr val="E8E8E8"/>
+                </a:solidFill>
+              </a:rPr>
+              <a:t>4. RocketRide: #showcase</a:t>
+            </a:r>
+          </a:p>
+          <a:p>
+            <a:pPr>
+              <a:spcAft>
+                <a:spcPts val="1000"/>
+              </a:spcAft>
+            </a:pPr>
+            <a:r>
+              <a:rPr sz="2200">
+                <a:solidFill>
+                  <a:srgbClr val="E8E8E8"/>
+                </a:solidFill>
+              </a:rPr>
+              <a:t>Repo: github.com/donaldc11/vigil-ai-night-staff</a:t>
+            </a:r>
+          </a:p>
+          <a:p>
+            <a:pPr>
+              <a:spcAft>
+                <a:spcPts val="1000"/>
+              </a:spcAft>
+            </a:pPr>
+            <a:r>
+              <a:rPr sz="2200">
+                <a:solidFill>
+                  <a:srgbClr val="E8E8E8"/>
+                </a:solidFill>
+              </a:rPr>
+              <a:t>Live page: donaldc11.github.io/vigil-ai-night-staff</a:t>
+            </a:r>
+          </a:p>
+        </p:txBody>
+      </p:sp>
+      <p:sp>
+        <p:nvSpPr>
+          <p:cNvPr id="4" name="TextBox 3"/>
+          <p:cNvSpPr txBox="1"/>
+          <p:nvPr/>
+        </p:nvSpPr>
+        <p:spPr>
+          <a:xfrm>
+            <a:off x="640080" y="6309360"/>
+            <a:ext cx="10972800" cy="365760"/>
+          </a:xfrm>
+          <a:prstGeom prst="rect">
+            <a:avLst/>
+          </a:prstGeom>
+          <a:noFill/>
+        </p:spPr>
+        <p:txBody>
+          <a:bodyPr wrap="none">
+            <a:spAutoFit/>
+          </a:bodyPr>
+          <a:lstStyle/>
+          <a:p>
+            <a:r>
+              <a:rPr sz="1200">
+                <a:solidFill>
+                  <a:srgbClr val="AAAAAA"/>
+                </a:solidFill>
+              </a:rPr>
+              <a:t>Fictional data. Each sponsor integration shows its true mode; no real call is placed.</a:t>
+            </a:r>
+          </a:p>
+        </p:txBody>
+      </p:sp>
+    </p:spTree>
+  </p:cSld>
+  <p:clrMapOvr>
+    <a:masterClrMapping/>
+  </p:clrMapOvr>
+</p:sld>
+</file>
+
+<file path=ppt/slides/slide8.xml><?xml version="1.0" encoding="utf-8"?>
 <p:sld xmlns:a="http://schemas.openxmlformats.org/drawingml/2006/main" xmlns:p="http://schemas.openxmlformats.org/presentationml/2006/main" xmlns:r="http://schemas.openxmlformats.org/officeDocument/2006/relationships">
   <p:cSld>
     <p:bg>

</xml_diff>

<commit_message>
Vigil: tighten pitch and remove unused sponsor module
</commit_message>
<xml_diff>
--- a/Vigil_deck.pptx
+++ b/Vigil_deck.pptx
@@ -5460,7 +5460,7 @@
                   <a:srgbClr val="E8E8E8"/>
                 </a:solidFill>
               </a:rPr>
-              <a:t>Every run reports which steps were real, simulated, fallback or external (55 automated tests).</a:t>
+              <a:t>Every run reports which steps were real, simulated, fallback or external (101 automated tests).</a:t>
             </a:r>
           </a:p>
           <a:p>
@@ -5825,7 +5825,7 @@
                   <a:srgbClr val="E8E8E8"/>
                 </a:solidFill>
               </a:rPr>
-              <a:t>Swap mock adapters for live integrations, one at a time.</a:t>
+              <a:t>Replace the remaining simulated adapters (RocketRide, PromptQL, Flatkey, Masky) with live integrations.</a:t>
             </a:r>
           </a:p>
           <a:p>

</xml_diff>

<commit_message>
Verify RocketRide and Masky sponsor integrations
</commit_message>
<xml_diff>
--- a/Vigil_deck.pptx
+++ b/Vigil_deck.pptx
@@ -5300,7 +5300,7 @@
                   <a:srgbClr val="E8E8E8"/>
                 </a:solidFill>
               </a:rPr>
-              <a:t>Masky: avatar portraits for the six agents</a:t>
+              <a:t>Masky: avatar for the family message: avatar lookup and a rendered speak-mode video turn, read back from the Masky API</a:t>
             </a:r>
           </a:p>
           <a:p>
@@ -5315,7 +5315,7 @@
                   <a:srgbClr val="E8E8E8"/>
                 </a:solidFill>
               </a:rPr>
-              <a:t>Recorded run: REAL = n8n, Snyk, BAND, Celesto, Paritok, Glasser, Tenki (sandbox runs Vera's lint). EXTERNAL = Prelint, Tenki CI (repo-side). SIMULATED = RocketRide, PromptQL, Flatkey, Masky. PromptQL: 3/3 verified answers in the PromptQL workspace on the pasted price list and ledger; no runtime API call. Masky: six portraits generated in Masky (real assets); no runtime API call.</a:t>
+              <a:t>Recorded run: REAL = n8n, Snyk, BAND, Celesto, Paritok, Glasser, Tenki (sandbox runs Vera's lint), RocketRide (self-hosted engine), Masky (avatar and rendered video turn read back from its API). EXTERNAL = Prelint, Tenki CI (repo-side). SIMULATED = PromptQL, Flatkey. PromptQL: 3/3 verified answers in the PromptQL workspace on the pasted price list and ledger; no runtime API call. Masky: portraits and clips hand-generated in Masky; only the build-time read-back is a live API call.</a:t>
             </a:r>
           </a:p>
         </p:txBody>
@@ -5825,7 +5825,7 @@
                   <a:srgbClr val="E8E8E8"/>
                 </a:solidFill>
               </a:rPr>
-              <a:t>Replace the remaining simulated adapters (RocketRide, PromptQL, Flatkey, Masky) with live integrations.</a:t>
+              <a:t>Replace the remaining simulated adapters (PromptQL, Flatkey) with live integrations.</a:t>
             </a:r>
           </a:p>
           <a:p>

</xml_diff>

<commit_message>
Add Flatkey gateway connectivity check
</commit_message>
<xml_diff>
--- a/Vigil_deck.pptx
+++ b/Vigil_deck.pptx
@@ -5285,7 +5285,7 @@
                   <a:srgbClr val="E8E8E8"/>
                 </a:solidFill>
               </a:rPr>
-              <a:t>Flatkey: model API / failover gateway (not a key vault)</a:t>
+              <a:t>Flatkey: model API gateway: one chat-completion call through Flatkey's OpenAI-compatible router (a gateway, not a key vault)</a:t>
             </a:r>
           </a:p>
           <a:p>
@@ -5315,7 +5315,7 @@
                   <a:srgbClr val="E8E8E8"/>
                 </a:solidFill>
               </a:rPr>
-              <a:t>Recorded run: REAL = n8n, Snyk, BAND, Celesto, Paritok, Glasser, Tenki (sandbox runs Vera's lint), RocketRide (self-hosted engine), Masky (avatar and rendered video turn read back from its API). EXTERNAL = Prelint, Tenki CI (repo-side). SIMULATED = PromptQL, Flatkey. PromptQL: 3/3 verified answers in the PromptQL workspace on the pasted price list and ledger; no runtime API call. Masky: portraits and clips hand-generated in Masky; only the build-time read-back is a live API call.</a:t>
+              <a:t>Recorded run: REAL = n8n, Snyk, BAND, Celesto, Paritok, Glasser, Tenki (sandbox runs Vera's lint), RocketRide (self-hosted engine), Masky (avatar and rendered video turn read back from its API), Flatkey (one gateway call, not in the decision path). EXTERNAL = Prelint, Tenki CI (repo-side). SIMULATED = PromptQL. PromptQL: 3/3 verified answers in the PromptQL workspace on the pasted price list and ledger; no runtime API call. Masky: portraits and clips hand-generated in Masky; only the build-time read-back is a live API call.</a:t>
             </a:r>
           </a:p>
         </p:txBody>
@@ -5825,7 +5825,7 @@
                   <a:srgbClr val="E8E8E8"/>
                 </a:solidFill>
               </a:rPr>
-              <a:t>Replace the remaining simulated adapters (PromptQL, Flatkey) with live integrations.</a:t>
+              <a:t>Replace the remaining simulated adapters (PromptQL) with live integrations.</a:t>
             </a:r>
           </a:p>
           <a:p>

</xml_diff>